<commit_message>
prelim results 1 - switched to lbs
</commit_message>
<xml_diff>
--- a/docs/presentations/Prelim1_Cody_Grandt.pptx
+++ b/docs/presentations/Prelim1_Cody_Grandt.pptx
@@ -4962,10 +4962,9 @@
               <a:t>Preliminary Results 1</a:t>
             </a:r>
           </a:p>
-          <a:p/>
-          <a:p>
-            <a:r>
-              <a:t>Project: Neural Network-Based Strength &amp; Volume Optimization Engine</a:t>
+          <a:p>
+            <a:r>
+              <a:t>Project: Strength &amp; Volume Optimization Engine</a:t>
             </a:r>
           </a:p>
         </p:txBody>
@@ -4986,7 +4985,7 @@
           <a:lstStyle/>
           <a:p>
             <a:r>
-              <a:t>Cody Grandt</a:t>
+              <a:t>Neural Network-Based  |  Cody Grandt</a:t>
             </a:r>
           </a:p>
         </p:txBody>

</xml_diff>